<commit_message>
Talk deck v4.1.1, deck set moved to v4.1.1 with shardic-crypt repo links, paper B.4 crack-time fix
- Conference talk deck v4.1.1: vault pipeline + zero-leakage indexing,
  shardic-prime, two kinds of strength, bypass-resistance ladder, and a
  codeword-strength backup slide; speaker set, notes retimed
- Overview/foundations rebuilt as v4.1.1; v4.1 decks kept unchanged
- Repo links point at github.com/splashd1/shardic-crypt (decks, v3.2
  deck, release-runner agent, README/pitch/explainer)
- White paper v4.1 appendix B.4: 30 -> 40 billion years (20 on average)
- Ignore LibreOffice lock files; session notes

Fine-tuned, vetted, and, in some cases, supplemented by Claude Sonnet 5
</commit_message>
<xml_diff>
--- a/docs/shardic_deck_v3_2.pptx
+++ b/docs/shardic_deck_v3_2.pptx
@@ -5278,7 +5278,7 @@
                 <a:cs typeface="Calibri"/>
                 <a:sym typeface="Calibri"/>
               </a:rPr>
-              <a:t>github.com/splashd1/shardic</a:t>
+              <a:t>github.com/splashd1/shardic-crypt</a:t>
             </a:r>
             <a:endParaRPr b="0" i="0" sz="1200" u="none" cap="none" strike="noStrike">
               <a:solidFill>
@@ -31716,7 +31716,7 @@
                 <a:cs typeface="Calibri"/>
                 <a:sym typeface="Calibri"/>
               </a:rPr>
-              <a:t>github.com/splashd1/shardic</a:t>
+              <a:t>github.com/splashd1/shardic-crypt</a:t>
             </a:r>
             <a:endParaRPr b="0" i="0" sz="1300" u="none" cap="none" strike="noStrike">
               <a:solidFill>

</xml_diff>